<commit_message>
Backup slide: stressor burden by trauma exposure figure
Co-Authored-By: Claude Fable 5 <noreply@anthropic.com>
Claude-Session: https://claude.ai/code/session_019BJ4u1WYcsA14q2B552n7R
</commit_message>
<xml_diff>
--- a/projects/marvin-stress-trauma/istss_mohammed_full.pptx
+++ b/projects/marvin-stress-trauma/istss_mohammed_full.pptx
@@ -23,6 +23,7 @@
     <p:sldId id="271" r:id="rId27"/>
     <p:sldId id="272" r:id="rId28"/>
     <p:sldId id="273" r:id="rId29"/>
+    <p:sldId id="274" r:id="rId30"/>
   </p:sldIdLst>
   <p:sldSz cx="12192000" cy="6858000"/>
   <p:notesSz cx="6858000" cy="9144000"/>
@@ -1609,6 +1610,76 @@
 </p:notes>
 </file>
 
+<file path=ppt/notesSlides/notesSlide19.xml><?xml version="1.0" encoding="utf-8"?>
+<p:notes xmlns:a="http://schemas.openxmlformats.org/drawingml/2006/main" xmlns:p="http://schemas.openxmlformats.org/presentationml/2006/main" xmlns:r="http://schemas.openxmlformats.org/officeDocument/2006/relationships">
+  <p:cSld>
+    <p:spTree>
+      <p:nvGrpSpPr>
+        <p:cNvPr id="1" name=""/>
+        <p:cNvGrpSpPr/>
+        <p:nvPr/>
+      </p:nvGrpSpPr>
+      <p:grpSpPr>
+        <a:xfrm>
+          <a:off x="0" y="0"/>
+          <a:ext cx="0" cy="0"/>
+          <a:chOff x="0" y="0"/>
+          <a:chExt cx="0" cy="0"/>
+        </a:xfrm>
+      </p:grpSpPr>
+      <p:sp>
+        <p:nvSpPr>
+          <p:cNvPr id="2" name="Slide Image Placeholder 1"/>
+          <p:cNvSpPr>
+            <a:spLocks noGrp="1"/>
+          </p:cNvSpPr>
+          <p:nvPr>
+            <p:ph type="sldImg" idx="2"/>
+          </p:nvPr>
+        </p:nvSpPr>
+        <p:spPr/>
+      </p:sp>
+      <p:sp>
+        <p:nvSpPr>
+          <p:cNvPr id="3" name="Notes Placeholder 2"/>
+          <p:cNvSpPr>
+            <a:spLocks noGrp="1"/>
+          </p:cNvSpPr>
+          <p:nvPr>
+            <p:ph type="body" idx="3" sz="quarter"/>
+          </p:nvPr>
+        </p:nvSpPr>
+        <p:spPr/>
+        <p:txBody>
+          <a:bodyPr/>
+          <a:lstStyle/>
+          <a:p>
+            <a:r>
+              <a:t>Backup for the artifact question. Two points in one figure. First, stressor burden rises with trauma — mean count quadruples from 1.2 to 5.2 across categories — which is exactly why the interaction needed formal, adjusted testing rather than eyeballing. Second, the gray bars are the full observed range and the colored whiskers are one SD: the five-plus group has the WIDEST stressor spread in the sample (SD 2.35, range 0 to 10). Its null stressor effect is estimated over more variation than any other group's — not a compressed range. Add the continuous-score results and the fading interaction survives every route to an artifact.</a:t>
+            </a:r>
+          </a:p>
+        </p:txBody>
+      </p:sp>
+      <p:sp>
+        <p:nvSpPr>
+          <p:cNvPr id="4" name="Slide Number Placeholder 3"/>
+          <p:cNvSpPr>
+            <a:spLocks noGrp="1"/>
+          </p:cNvSpPr>
+          <p:nvPr>
+            <p:ph type="sldNum" idx="5" sz="quarter"/>
+          </p:nvPr>
+        </p:nvSpPr>
+        <p:spPr/>
+      </p:sp>
+    </p:spTree>
+  </p:cSld>
+  <p:clrMapOvr>
+    <a:masterClrMapping/>
+  </p:clrMapOvr>
+</p:notes>
+</file>
+
 <file path=ppt/notesSlides/notesSlide2.xml><?xml version="1.0" encoding="utf-8"?>
 <p:notes xmlns:a="http://schemas.openxmlformats.org/drawingml/2006/main" xmlns:p="http://schemas.openxmlformats.org/presentationml/2006/main" xmlns:r="http://schemas.openxmlformats.org/officeDocument/2006/relationships">
   <p:cSld>
@@ -5685,6 +5756,69 @@
           </a:p>
         </p:txBody>
       </p:sp>
+    </p:spTree>
+  </p:cSld>
+  <p:clrMapOvr>
+    <a:masterClrMapping/>
+  </p:clrMapOvr>
+</p:sld>
+</file>
+
+<file path=ppt/slides/slide19.xml><?xml version="1.0" encoding="utf-8"?>
+<p:sld xmlns:a="http://schemas.openxmlformats.org/drawingml/2006/main" xmlns:p="http://schemas.openxmlformats.org/presentationml/2006/main" xmlns:r="http://schemas.openxmlformats.org/officeDocument/2006/relationships">
+  <p:cSld>
+    <p:spTree>
+      <p:nvGrpSpPr>
+        <p:cNvPr id="1" name=""/>
+        <p:cNvGrpSpPr/>
+        <p:nvPr/>
+      </p:nvGrpSpPr>
+      <p:grpSpPr/>
+      <p:sp>
+        <p:nvSpPr>
+          <p:cNvPr id="2" name="Title 1"/>
+          <p:cNvSpPr>
+            <a:spLocks noGrp="1"/>
+          </p:cNvSpPr>
+          <p:nvPr>
+            <p:ph type="title"/>
+          </p:nvPr>
+        </p:nvSpPr>
+        <p:spPr/>
+        <p:txBody>
+          <a:bodyPr/>
+          <a:lstStyle/>
+          <a:p>
+            <a:r>
+              <a:t>Backup: The Two Exposures Are Correlated — and the Null Is Not Range Restriction</a:t>
+            </a:r>
+          </a:p>
+        </p:txBody>
+      </p:sp>
+      <p:pic>
+        <p:nvPicPr>
+          <p:cNvPr id="3" name="Picture 2" descr="stressor_by_trauma.png"/>
+          <p:cNvPicPr>
+            <a:picLocks noChangeAspect="1"/>
+          </p:cNvPicPr>
+          <p:nvPr/>
+        </p:nvPicPr>
+        <p:blipFill>
+          <a:blip r:embed="rId2"/>
+          <a:stretch>
+            <a:fillRect/>
+          </a:stretch>
+        </p:blipFill>
+        <p:spPr>
+          <a:xfrm>
+            <a:off x="1371600" y="1554480"/>
+            <a:ext cx="9418320" cy="5185367"/>
+          </a:xfrm>
+          <a:prstGeom prst="rect">
+            <a:avLst/>
+          </a:prstGeom>
+        </p:spPr>
+      </p:pic>
     </p:spTree>
   </p:cSld>
   <p:clrMapOvr>

</xml_diff>

<commit_message>
Slide: spline-estimated stressor effect along the trauma curve
Co-Authored-By: Claude Fable 5 <noreply@anthropic.com>
Claude-Session: https://claude.ai/code/session_019BJ4u1WYcsA14q2B552n7R
</commit_message>
<xml_diff>
--- a/projects/marvin-stress-trauma/istss_mohammed_full.pptx
+++ b/projects/marvin-stress-trauma/istss_mohammed_full.pptx
@@ -24,6 +24,7 @@
     <p:sldId id="272" r:id="rId28"/>
     <p:sldId id="273" r:id="rId29"/>
     <p:sldId id="274" r:id="rId30"/>
+    <p:sldId id="275" r:id="rId31"/>
   </p:sldIdLst>
   <p:sldSz cx="12192000" cy="6858000"/>
   <p:notesSz cx="6858000" cy="9144000"/>
@@ -1750,6 +1751,76 @@
 </p:notes>
 </file>
 
+<file path=ppt/notesSlides/notesSlide20.xml><?xml version="1.0" encoding="utf-8"?>
+<p:notes xmlns:a="http://schemas.openxmlformats.org/drawingml/2006/main" xmlns:p="http://schemas.openxmlformats.org/presentationml/2006/main" xmlns:r="http://schemas.openxmlformats.org/officeDocument/2006/relationships">
+  <p:cSld>
+    <p:spTree>
+      <p:nvGrpSpPr>
+        <p:cNvPr id="1" name=""/>
+        <p:cNvGrpSpPr/>
+        <p:nvPr/>
+      </p:nvGrpSpPr>
+      <p:grpSpPr>
+        <a:xfrm>
+          <a:off x="0" y="0"/>
+          <a:ext cx="0" cy="0"/>
+          <a:chOff x="0" y="0"/>
+          <a:chExt cx="0" cy="0"/>
+        </a:xfrm>
+      </p:grpSpPr>
+      <p:sp>
+        <p:nvSpPr>
+          <p:cNvPr id="2" name="Slide Image Placeholder 1"/>
+          <p:cNvSpPr>
+            <a:spLocks noGrp="1"/>
+          </p:cNvSpPr>
+          <p:nvPr>
+            <p:ph type="sldImg" idx="2"/>
+          </p:nvPr>
+        </p:nvSpPr>
+        <p:spPr/>
+      </p:sp>
+      <p:sp>
+        <p:nvSpPr>
+          <p:cNvPr id="3" name="Notes Placeholder 2"/>
+          <p:cNvSpPr>
+            <a:spLocks noGrp="1"/>
+          </p:cNvSpPr>
+          <p:nvPr>
+            <p:ph type="body" idx="3" sz="quarter"/>
+          </p:nvPr>
+        </p:nvSpPr>
+        <p:spPr/>
+        <p:txBody>
+          <a:bodyPr/>
+          <a:lstStyle/>
+          <a:p>
+            <a:r>
+              <a:t>This is the spline, shown as what it estimates: the prevalence ratio per additional stressor, as a continuous function of the trauma count. The dark curve comes from the adjusted model with trauma as a restricted cubic spline, knots at 0, 2, and 5 — free to rise (sensitization), stay flat (additivity), or fall. It falls, smoothly and monotonically, crossing the null just past four events. The red dots are the secondary categorical specification with confidence intervals — the two approaches agree on the shape; the gap at zero reflects adjustment (the categorical estimates are unadjusted). No bins imposed this: the curve chose it.</a:t>
+            </a:r>
+          </a:p>
+        </p:txBody>
+      </p:sp>
+      <p:sp>
+        <p:nvSpPr>
+          <p:cNvPr id="4" name="Slide Number Placeholder 3"/>
+          <p:cNvSpPr>
+            <a:spLocks noGrp="1"/>
+          </p:cNvSpPr>
+          <p:nvPr>
+            <p:ph type="sldNum" idx="5" sz="quarter"/>
+          </p:nvPr>
+        </p:nvSpPr>
+        <p:spPr/>
+      </p:sp>
+    </p:spTree>
+  </p:cSld>
+  <p:clrMapOvr>
+    <a:masterClrMapping/>
+  </p:clrMapOvr>
+</p:notes>
+</file>
+
 <file path=ppt/notesSlides/notesSlide3.xml><?xml version="1.0" encoding="utf-8"?>
 <p:notes xmlns:a="http://schemas.openxmlformats.org/drawingml/2006/main" xmlns:p="http://schemas.openxmlformats.org/presentationml/2006/main" xmlns:r="http://schemas.openxmlformats.org/officeDocument/2006/relationships">
   <p:cSld>
@@ -6051,6 +6122,69 @@
         <p14:creationId xmlns:p14="http://schemas.microsoft.com/office/powerpoint/2010/main" val="1217370416"/>
       </p:ext>
     </p:extLst>
+  </p:cSld>
+  <p:clrMapOvr>
+    <a:masterClrMapping/>
+  </p:clrMapOvr>
+</p:sld>
+</file>
+
+<file path=ppt/slides/slide20.xml><?xml version="1.0" encoding="utf-8"?>
+<p:sld xmlns:a="http://schemas.openxmlformats.org/drawingml/2006/main" xmlns:p="http://schemas.openxmlformats.org/presentationml/2006/main" xmlns:r="http://schemas.openxmlformats.org/officeDocument/2006/relationships">
+  <p:cSld>
+    <p:spTree>
+      <p:nvGrpSpPr>
+        <p:cNvPr id="1" name=""/>
+        <p:cNvGrpSpPr/>
+        <p:nvPr/>
+      </p:nvGrpSpPr>
+      <p:grpSpPr/>
+      <p:sp>
+        <p:nvSpPr>
+          <p:cNvPr id="2" name="Title 1"/>
+          <p:cNvSpPr>
+            <a:spLocks noGrp="1"/>
+          </p:cNvSpPr>
+          <p:nvPr>
+            <p:ph type="title"/>
+          </p:nvPr>
+        </p:nvSpPr>
+        <p:spPr/>
+        <p:txBody>
+          <a:bodyPr/>
+          <a:lstStyle/>
+          <a:p>
+            <a:r>
+              <a:t>The Spline Itself: A Smoothly Declining Stressor Effect</a:t>
+            </a:r>
+          </a:p>
+        </p:txBody>
+      </p:sp>
+      <p:pic>
+        <p:nvPicPr>
+          <p:cNvPr id="3" name="Picture 2" descr="spline_effect.png"/>
+          <p:cNvPicPr>
+            <a:picLocks noChangeAspect="1"/>
+          </p:cNvPicPr>
+          <p:nvPr/>
+        </p:nvPicPr>
+        <p:blipFill>
+          <a:blip r:embed="rId2"/>
+          <a:stretch>
+            <a:fillRect/>
+          </a:stretch>
+        </p:blipFill>
+        <p:spPr>
+          <a:xfrm>
+            <a:off x="1280160" y="1508760"/>
+            <a:ext cx="9601200" cy="5781368"/>
+          </a:xfrm>
+          <a:prstGeom prst="rect">
+            <a:avLst/>
+          </a:prstGeom>
+        </p:spPr>
+      </p:pic>
+    </p:spTree>
   </p:cSld>
   <p:clrMapOvr>
     <a:masterClrMapping/>

</xml_diff>

<commit_message>
Spline figure with design-based CI band; fix margins spline-basis constants at t=5,7
Co-Authored-By: Claude Fable 5 <noreply@anthropic.com>
Claude-Session: https://claude.ai/code/session_019BJ4u1WYcsA14q2B552n7R
</commit_message>
<xml_diff>
--- a/projects/marvin-stress-trauma/istss_mohammed_full.pptx
+++ b/projects/marvin-stress-trauma/istss_mohammed_full.pptx
@@ -6169,7 +6169,7 @@
           <p:nvPr/>
         </p:nvPicPr>
         <p:blipFill>
-          <a:blip r:embed="rId2"/>
+          <a:blip r:embed="rId4"/>
           <a:stretch>
             <a:fillRect/>
           </a:stretch>
@@ -6177,7 +6177,7 @@
         <p:spPr>
           <a:xfrm>
             <a:off x="1280160" y="1508760"/>
-            <a:ext cx="9601200" cy="5781368"/>
+            <a:ext cx="9601200" cy="5628059"/>
           </a:xfrm>
           <a:prstGeom prst="rect">
             <a:avLst/>

</xml_diff>